<commit_message>
added N GRam Validation
</commit_message>
<xml_diff>
--- a/figures/schemas/CTB_pipeline_diagrams_black_white.pptx
+++ b/figures/schemas/CTB_pipeline_diagrams_black_white.pptx
@@ -2,14 +2,14 @@
 <file path=ppt/presentation.xml><?xml version="1.0" encoding="utf-8"?>
 <p:presentation xmlns:p="http://schemas.openxmlformats.org/presentationml/2006/main">
   <p:sldMasterIdLst>
-    <p:sldMasterId xmlns:r="http://schemas.openxmlformats.org/officeDocument/2006/relationships" id="2147483648" r:id="R111fb932f99c479d"/>
+    <p:sldMasterId xmlns:r="http://schemas.openxmlformats.org/officeDocument/2006/relationships" id="2147483648" r:id="R3f453b373518454c"/>
   </p:sldMasterIdLst>
   <p:notesMasterIdLst>
-    <p:notesMasterId xmlns:r="http://schemas.openxmlformats.org/officeDocument/2006/relationships" r:id="R707cd06a0fec43d2"/>
+    <p:notesMasterId xmlns:r="http://schemas.openxmlformats.org/officeDocument/2006/relationships" r:id="Rf86158adf41a4aaf"/>
   </p:notesMasterIdLst>
   <p:sldIdLst>
-    <p:sldId xmlns:r="http://schemas.openxmlformats.org/officeDocument/2006/relationships" id="256" r:id="Rdbdf04bfce564ab3"/>
-    <p:sldId xmlns:r="http://schemas.openxmlformats.org/officeDocument/2006/relationships" id="257" r:id="Rff7052aa888b4261"/>
+    <p:sldId xmlns:r="http://schemas.openxmlformats.org/officeDocument/2006/relationships" id="256" r:id="Ra450d66706bb4ea5"/>
+    <p:sldId xmlns:r="http://schemas.openxmlformats.org/officeDocument/2006/relationships" id="257" r:id="R6e263bce7ffa49c2"/>
   </p:sldIdLst>
   <p:sldSz cx="12192000" cy="6858000"/>
   <p:notesSz cx="6858000" cy="9144000"/>
@@ -611,7 +611,7 @@
   </p:cSld>
   <p:clrMap bg1="lt1" tx1="dk1" bg2="lt2" tx2="dk2" accent1="accent1" accent2="accent2" accent3="accent3" accent4="accent4" accent5="accent5" accent6="accent6" hlink="hlink" folHlink="folHlink"/>
   <p:sldLayoutIdLst>
-    <p:sldLayoutId xmlns:r="http://schemas.openxmlformats.org/officeDocument/2006/relationships" id="2147483649" r:id="R0540261f8e9e46d4"/>
+    <p:sldLayoutId xmlns:r="http://schemas.openxmlformats.org/officeDocument/2006/relationships" id="2147483649" r:id="Rdabce3b1794640ed"/>
   </p:sldLayoutIdLst>
   <p:txStyles>
     <p:titleStyle>
@@ -1508,7 +1508,7 @@
       </p:sp>
       <p:cxnSp>
         <p:nvCxnSpPr>
-          <p:cNvPr id="111" name=""/>
+          <p:cNvPr id="149" name=""/>
           <p:cNvCxnSpPr>
             <a:stCxn xmlns:a="http://schemas.openxmlformats.org/drawingml/2006/main" id="3" idx="3"/>
             <a:endCxn xmlns:a="http://schemas.openxmlformats.org/drawingml/2006/main" id="4" idx="1"/>
@@ -1534,7 +1534,7 @@
       </p:cxnSp>
       <p:cxnSp>
         <p:nvCxnSpPr>
-          <p:cNvPr id="112" name=""/>
+          <p:cNvPr id="150" name=""/>
           <p:cNvCxnSpPr>
             <a:stCxn xmlns:a="http://schemas.openxmlformats.org/drawingml/2006/main" id="4" idx="3"/>
             <a:endCxn xmlns:a="http://schemas.openxmlformats.org/drawingml/2006/main" id="5" idx="1"/>
@@ -1560,7 +1560,7 @@
       </p:cxnSp>
       <p:cxnSp>
         <p:nvCxnSpPr>
-          <p:cNvPr id="113" name=""/>
+          <p:cNvPr id="151" name=""/>
           <p:cNvCxnSpPr>
             <a:stCxn xmlns:a="http://schemas.openxmlformats.org/drawingml/2006/main" id="5" idx="3"/>
             <a:endCxn xmlns:a="http://schemas.openxmlformats.org/drawingml/2006/main" id="6" idx="1"/>
@@ -1586,7 +1586,7 @@
       </p:cxnSp>
       <p:cxnSp>
         <p:nvCxnSpPr>
-          <p:cNvPr id="114" name=""/>
+          <p:cNvPr id="152" name=""/>
           <p:cNvCxnSpPr>
             <a:stCxn xmlns:a="http://schemas.openxmlformats.org/drawingml/2006/main" id="6" idx="3"/>
             <a:endCxn xmlns:a="http://schemas.openxmlformats.org/drawingml/2006/main" id="7" idx="1"/>
@@ -1612,7 +1612,7 @@
       </p:cxnSp>
       <p:cxnSp>
         <p:nvCxnSpPr>
-          <p:cNvPr id="115" name=""/>
+          <p:cNvPr id="153" name=""/>
           <p:cNvCxnSpPr>
             <a:stCxn xmlns:a="http://schemas.openxmlformats.org/drawingml/2006/main" id="7" idx="3"/>
             <a:endCxn xmlns:a="http://schemas.openxmlformats.org/drawingml/2006/main" id="8" idx="3"/>
@@ -1638,7 +1638,7 @@
       </p:cxnSp>
       <p:cxnSp>
         <p:nvCxnSpPr>
-          <p:cNvPr id="116" name=""/>
+          <p:cNvPr id="154" name=""/>
           <p:cNvCxnSpPr>
             <a:stCxn xmlns:a="http://schemas.openxmlformats.org/drawingml/2006/main" id="8" idx="1"/>
             <a:endCxn xmlns:a="http://schemas.openxmlformats.org/drawingml/2006/main" id="9" idx="3"/>
@@ -1664,7 +1664,7 @@
       </p:cxnSp>
       <p:cxnSp>
         <p:nvCxnSpPr>
-          <p:cNvPr id="117" name=""/>
+          <p:cNvPr id="155" name=""/>
           <p:cNvCxnSpPr>
             <a:stCxn xmlns:a="http://schemas.openxmlformats.org/drawingml/2006/main" id="9" idx="1"/>
             <a:endCxn xmlns:a="http://schemas.openxmlformats.org/drawingml/2006/main" id="10" idx="3"/>
@@ -1690,7 +1690,7 @@
       </p:cxnSp>
       <p:cxnSp>
         <p:nvCxnSpPr>
-          <p:cNvPr id="118" name=""/>
+          <p:cNvPr id="156" name=""/>
           <p:cNvCxnSpPr>
             <a:stCxn xmlns:a="http://schemas.openxmlformats.org/drawingml/2006/main" id="10" idx="1"/>
             <a:endCxn xmlns:a="http://schemas.openxmlformats.org/drawingml/2006/main" id="11" idx="3"/>
@@ -3592,7 +3592,7 @@
       </p:sp>
       <p:cxnSp>
         <p:nvCxnSpPr>
-          <p:cNvPr id="144" name=""/>
+          <p:cNvPr id="194" name=""/>
           <p:cNvCxnSpPr>
             <a:stCxn xmlns:a="http://schemas.openxmlformats.org/drawingml/2006/main" id="3" idx="3"/>
             <a:endCxn xmlns:a="http://schemas.openxmlformats.org/drawingml/2006/main" id="4" idx="1"/>
@@ -3618,7 +3618,7 @@
       </p:cxnSp>
       <p:cxnSp>
         <p:nvCxnSpPr>
-          <p:cNvPr id="145" name=""/>
+          <p:cNvPr id="195" name=""/>
           <p:cNvCxnSpPr>
             <a:stCxn xmlns:a="http://schemas.openxmlformats.org/drawingml/2006/main" id="4" idx="3"/>
             <a:endCxn xmlns:a="http://schemas.openxmlformats.org/drawingml/2006/main" id="5" idx="1"/>
@@ -3644,7 +3644,7 @@
       </p:cxnSp>
       <p:cxnSp>
         <p:nvCxnSpPr>
-          <p:cNvPr id="146" name=""/>
+          <p:cNvPr id="196" name=""/>
           <p:cNvCxnSpPr>
             <a:stCxn xmlns:a="http://schemas.openxmlformats.org/drawingml/2006/main" id="5" idx="3"/>
             <a:endCxn xmlns:a="http://schemas.openxmlformats.org/drawingml/2006/main" id="6" idx="1"/>
@@ -3670,7 +3670,7 @@
       </p:cxnSp>
       <p:cxnSp>
         <p:nvCxnSpPr>
-          <p:cNvPr id="147" name=""/>
+          <p:cNvPr id="197" name=""/>
           <p:cNvCxnSpPr>
             <a:stCxn xmlns:a="http://schemas.openxmlformats.org/drawingml/2006/main" id="6" idx="3"/>
             <a:endCxn xmlns:a="http://schemas.openxmlformats.org/drawingml/2006/main" id="7" idx="1"/>
@@ -3696,7 +3696,7 @@
       </p:cxnSp>
       <p:cxnSp>
         <p:nvCxnSpPr>
-          <p:cNvPr id="148" name=""/>
+          <p:cNvPr id="198" name=""/>
           <p:cNvCxnSpPr>
             <a:stCxn xmlns:a="http://schemas.openxmlformats.org/drawingml/2006/main" id="7" idx="3"/>
             <a:endCxn xmlns:a="http://schemas.openxmlformats.org/drawingml/2006/main" id="8" idx="3"/>
@@ -3722,7 +3722,7 @@
       </p:cxnSp>
       <p:cxnSp>
         <p:nvCxnSpPr>
-          <p:cNvPr id="149" name=""/>
+          <p:cNvPr id="199" name=""/>
           <p:cNvCxnSpPr>
             <a:stCxn xmlns:a="http://schemas.openxmlformats.org/drawingml/2006/main" id="8" idx="1"/>
             <a:endCxn xmlns:a="http://schemas.openxmlformats.org/drawingml/2006/main" id="9" idx="3"/>
@@ -3748,7 +3748,7 @@
       </p:cxnSp>
       <p:cxnSp>
         <p:nvCxnSpPr>
-          <p:cNvPr id="150" name=""/>
+          <p:cNvPr id="200" name=""/>
           <p:cNvCxnSpPr>
             <a:stCxn xmlns:a="http://schemas.openxmlformats.org/drawingml/2006/main" id="9" idx="1"/>
             <a:endCxn xmlns:a="http://schemas.openxmlformats.org/drawingml/2006/main" id="10" idx="3"/>
@@ -3774,7 +3774,7 @@
       </p:cxnSp>
       <p:cxnSp>
         <p:nvCxnSpPr>
-          <p:cNvPr id="151" name=""/>
+          <p:cNvPr id="201" name=""/>
           <p:cNvCxnSpPr>
             <a:stCxn xmlns:a="http://schemas.openxmlformats.org/drawingml/2006/main" id="10" idx="1"/>
             <a:endCxn xmlns:a="http://schemas.openxmlformats.org/drawingml/2006/main" id="11" idx="3"/>
@@ -3800,7 +3800,7 @@
       </p:cxnSp>
       <p:cxnSp>
         <p:nvCxnSpPr>
-          <p:cNvPr id="152" name=""/>
+          <p:cNvPr id="202" name=""/>
           <p:cNvCxnSpPr>
             <a:stCxn xmlns:a="http://schemas.openxmlformats.org/drawingml/2006/main" id="11" idx="1"/>
             <a:endCxn xmlns:a="http://schemas.openxmlformats.org/drawingml/2006/main" id="12" idx="1"/>
@@ -3826,7 +3826,7 @@
       </p:cxnSp>
       <p:cxnSp>
         <p:nvCxnSpPr>
-          <p:cNvPr id="153" name=""/>
+          <p:cNvPr id="203" name=""/>
           <p:cNvCxnSpPr>
             <a:stCxn xmlns:a="http://schemas.openxmlformats.org/drawingml/2006/main" id="12" idx="3"/>
             <a:endCxn xmlns:a="http://schemas.openxmlformats.org/drawingml/2006/main" id="13" idx="1"/>
@@ -3852,7 +3852,7 @@
       </p:cxnSp>
       <p:cxnSp>
         <p:nvCxnSpPr>
-          <p:cNvPr id="154" name=""/>
+          <p:cNvPr id="204" name=""/>
           <p:cNvCxnSpPr>
             <a:stCxn xmlns:a="http://schemas.openxmlformats.org/drawingml/2006/main" id="13" idx="3"/>
             <a:endCxn xmlns:a="http://schemas.openxmlformats.org/drawingml/2006/main" id="14" idx="1"/>
@@ -4603,7 +4603,7 @@
                 <a:ea typeface="Arial"/>
                 <a:cs typeface="Arial"/>
               </a:rPr>
-              <a:t>no-rules, rules and rules + workload configurations</a:t>
+              <a:t>2x2: static proxies off/on; native state off/on</a:t>
             </a:r>
           </a:p>
         </p:txBody>
@@ -4666,7 +4666,7 @@
                 <a:ea typeface="Arial"/>
                 <a:cs typeface="Arial"/>
               </a:rPr>
-              <a:t>Freeze and calibrate</a:t>
+              <a:t>Freeze bundles and cap RMGs</a:t>
             </a:r>
           </a:p>
         </p:txBody>
@@ -4701,7 +4701,7 @@
         </p:spPr>
         <p:txBody>
           <a:bodyPr xmlns:a="http://schemas.openxmlformats.org/drawingml/2006/main" lIns="19050" tIns="0" rIns="19050" bIns="0" anchor="t">
-            <a:normAutofit fontScale="100000"/>
+            <a:normAutofit fontScale="94591"/>
           </a:bodyPr>
           <a:lstStyle xmlns:a="http://schemas.openxmlformats.org/drawingml/2006/main"/>
           <a:p xmlns:a="http://schemas.openxmlformats.org/drawingml/2006/main">
@@ -4725,7 +4725,7 @@
                 <a:ea typeface="Arial"/>
                 <a:cs typeface="Arial"/>
               </a:rPr>
-              <a:t>Expert-validated RMG ceiling: three per block</a:t>
+              <a:t>Training-only bundles; max. three RMGs per block</a:t>
             </a:r>
           </a:p>
         </p:txBody>
@@ -4945,7 +4945,7 @@
         </p:spPr>
         <p:txBody>
           <a:bodyPr xmlns:a="http://schemas.openxmlformats.org/drawingml/2006/main" lIns="19050" tIns="0" rIns="19050" bIns="0" anchor="t">
-            <a:normAutofit fontScale="86766"/>
+            <a:normAutofit fontScale="91972"/>
           </a:bodyPr>
           <a:lstStyle xmlns:a="http://schemas.openxmlformats.org/drawingml/2006/main"/>
           <a:p xmlns:a="http://schemas.openxmlformats.org/drawingml/2006/main">
@@ -4969,7 +4969,7 @@
                 <a:ea typeface="Arial"/>
                 <a:cs typeface="Arial"/>
               </a:rPr>
-              <a:t>EMD, KS, KPI errors, activity rates and confidence intervals</a:t>
+              <a:t>EMD, KS, KPIs, activity-rate L1, 3-gram NGD and CIs</a:t>
             </a:r>
           </a:p>
         </p:txBody>
@@ -5067,7 +5067,7 @@
         </p:spPr>
         <p:txBody>
           <a:bodyPr xmlns:a="http://schemas.openxmlformats.org/drawingml/2006/main" lIns="19050" tIns="0" rIns="19050" bIns="0" anchor="t">
-            <a:normAutofit fontScale="92684"/>
+            <a:normAutofit fontScale="95491"/>
           </a:bodyPr>
           <a:lstStyle xmlns:a="http://schemas.openxmlformats.org/drawingml/2006/main"/>
           <a:p xmlns:a="http://schemas.openxmlformats.org/drawingml/2006/main">
@@ -5091,7 +5091,7 @@
                 <a:ea typeface="Arial"/>
                 <a:cs typeface="Arial"/>
               </a:rPr>
-              <a:t>Configuration, resource, transition and demand-saturation tests</a:t>
+              <a:t>Clean-static, structural, resource, transition and saturation tests</a:t>
             </a:r>
           </a:p>
         </p:txBody>
@@ -5626,7 +5626,7 @@
         </p:spPr>
         <p:txBody>
           <a:bodyPr xmlns:a="http://schemas.openxmlformats.org/drawingml/2006/main" lIns="47625" tIns="28575" rIns="47625" bIns="28575" anchor="ctr">
-            <a:normAutofit fontScale="61784"/>
+            <a:normAutofit fontScale="64403"/>
           </a:bodyPr>
           <a:lstStyle xmlns:a="http://schemas.openxmlformats.org/drawingml/2006/main"/>
           <a:p xmlns:a="http://schemas.openxmlformats.org/drawingml/2006/main">
@@ -5650,7 +5650,7 @@
                 <a:ea typeface="Arial"/>
                 <a:cs typeface="Arial"/>
               </a:rPr>
-              <a:t>EMD / KS / KPIs</a:t>
+              <a:t>EMD / L1 / NGD</a:t>
             </a:r>
           </a:p>
         </p:txBody>

</xml_diff>

<commit_message>
updatedpkl vs json usage
</commit_message>
<xml_diff>
--- a/figures/schemas/CTB_pipeline_diagrams_black_white.pptx
+++ b/figures/schemas/CTB_pipeline_diagrams_black_white.pptx
@@ -2,14 +2,14 @@
 <file path=ppt/presentation.xml><?xml version="1.0" encoding="utf-8"?>
 <p:presentation xmlns:p="http://schemas.openxmlformats.org/presentationml/2006/main">
   <p:sldMasterIdLst>
-    <p:sldMasterId xmlns:r="http://schemas.openxmlformats.org/officeDocument/2006/relationships" id="2147483648" r:id="R3f453b373518454c"/>
+    <p:sldMasterId xmlns:r="http://schemas.openxmlformats.org/officeDocument/2006/relationships" id="2147483648" r:id="R2de4d5b97004409a"/>
   </p:sldMasterIdLst>
   <p:notesMasterIdLst>
-    <p:notesMasterId xmlns:r="http://schemas.openxmlformats.org/officeDocument/2006/relationships" r:id="Rf86158adf41a4aaf"/>
+    <p:notesMasterId xmlns:r="http://schemas.openxmlformats.org/officeDocument/2006/relationships" r:id="R660ea85a02944a1a"/>
   </p:notesMasterIdLst>
   <p:sldIdLst>
-    <p:sldId xmlns:r="http://schemas.openxmlformats.org/officeDocument/2006/relationships" id="256" r:id="Ra450d66706bb4ea5"/>
-    <p:sldId xmlns:r="http://schemas.openxmlformats.org/officeDocument/2006/relationships" id="257" r:id="R6e263bce7ffa49c2"/>
+    <p:sldId xmlns:r="http://schemas.openxmlformats.org/officeDocument/2006/relationships" id="256" r:id="R49fb00642fee4f55"/>
+    <p:sldId xmlns:r="http://schemas.openxmlformats.org/officeDocument/2006/relationships" id="257" r:id="R5d6b9f7de2da4933"/>
   </p:sldIdLst>
   <p:sldSz cx="12192000" cy="6858000"/>
   <p:notesSz cx="6858000" cy="9144000"/>
@@ -611,7 +611,7 @@
   </p:cSld>
   <p:clrMap bg1="lt1" tx1="dk1" bg2="lt2" tx2="dk2" accent1="accent1" accent2="accent2" accent3="accent3" accent4="accent4" accent5="accent5" accent6="accent6" hlink="hlink" folHlink="folHlink"/>
   <p:sldLayoutIdLst>
-    <p:sldLayoutId xmlns:r="http://schemas.openxmlformats.org/officeDocument/2006/relationships" id="2147483649" r:id="Rdabce3b1794640ed"/>
+    <p:sldLayoutId xmlns:r="http://schemas.openxmlformats.org/officeDocument/2006/relationships" id="2147483649" r:id="R6966fa2bfb96439c"/>
   </p:sldLayoutIdLst>
   <p:txStyles>
     <p:titleStyle>
@@ -1159,22 +1159,22 @@
       </p:grpSpPr>
       <p:sp>
         <p:nvSpPr>
-          <p:cNvPr id="43" name="event-log-engineering-label">
-            <a:extLst xmlns:a="http://schemas.openxmlformats.org/drawingml/2006/main">
-              <a:ext uri="{FF2B5EF4-FFF2-40B4-BE49-F238E27FC236}">
-                <a16:creationId xmlns:a16="http://schemas.microsoft.com/office/drawing/2014/main" id="{C6B37C38-CA88-40F4-8FB4-C4F528FA6470}"/>
-              </a:ext>
-            </a:extLst>
-          </p:cNvPr>
-          <p:cNvSpPr>
-            <a:spLocks xmlns:a="http://schemas.openxmlformats.org/drawingml/2006/main" noGrp="1"/>
-          </p:cNvSpPr>
-          <p:nvPr/>
-        </p:nvSpPr>
-        <p:spPr>
-          <a:xfrm xmlns:a="http://schemas.openxmlformats.org/drawingml/2006/main">
-            <a:off x="457200" y="266700"/>
-            <a:ext cx="3714750" cy="266700"/>
+          <p:cNvPr id="3" name="sources-anchor">
+            <a:extLst xmlns:a="http://schemas.openxmlformats.org/drawingml/2006/main">
+              <a:ext uri="{FF2B5EF4-FFF2-40B4-BE49-F238E27FC236}">
+                <a16:creationId xmlns:a16="http://schemas.microsoft.com/office/drawing/2014/main" id="{FC02B011-BA08-4B21-B43A-215EA3C25AC4}"/>
+              </a:ext>
+            </a:extLst>
+          </p:cNvPr>
+          <p:cNvSpPr>
+            <a:spLocks xmlns:a="http://schemas.openxmlformats.org/drawingml/2006/main" noGrp="1"/>
+          </p:cNvSpPr>
+          <p:nvPr/>
+        </p:nvSpPr>
+        <p:spPr>
+          <a:xfrm xmlns:a="http://schemas.openxmlformats.org/drawingml/2006/main">
+            <a:off x="400050" y="1190625"/>
+            <a:ext cx="1504950" cy="1238250"/>
           </a:xfrm>
           <a:prstGeom xmlns:a="http://schemas.openxmlformats.org/drawingml/2006/main" prst="rect">
             <a:avLst/>
@@ -1185,84 +1185,25 @@
             <a:prstDash val="solid"/>
           </a:ln>
         </p:spPr>
-        <p:txBody>
-          <a:bodyPr xmlns:a="http://schemas.openxmlformats.org/drawingml/2006/main" anchor="ctr"/>
-          <a:lstStyle xmlns:a="http://schemas.openxmlformats.org/drawingml/2006/main"/>
-          <a:p xmlns:a="http://schemas.openxmlformats.org/drawingml/2006/main">
-            <a:pPr algn="l">
-              <a:buNone/>
-              <a:defRPr sz="1500" b="1">
-                <a:solidFill>
-                  <a:srgbClr val="5D5D5D"/>
-                </a:solidFill>
-                <a:latin typeface="Arial"/>
-                <a:ea typeface="Arial"/>
-                <a:cs typeface="Arial"/>
-              </a:defRPr>
-            </a:pPr>
-            <a:r>
-              <a:rPr sz="1500" b="1">
-                <a:solidFill>
-                  <a:srgbClr val="5D5D5D"/>
-                </a:solidFill>
-                <a:latin typeface="Arial"/>
-                <a:ea typeface="Arial"/>
-                <a:cs typeface="Arial"/>
-              </a:rPr>
-              <a:t>EVENT-LOG ENGINEERING</a:t>
-            </a:r>
-          </a:p>
-        </p:txBody>
-      </p:sp>
-      <p:sp>
-        <p:nvSpPr>
-          <p:cNvPr id="2" name="event-log-engineering-rule">
-            <a:extLst xmlns:a="http://schemas.openxmlformats.org/drawingml/2006/main">
-              <a:ext uri="{FF2B5EF4-FFF2-40B4-BE49-F238E27FC236}">
-                <a16:creationId xmlns:a16="http://schemas.microsoft.com/office/drawing/2014/main" id="{FEC5DBBB-C6EB-4F3B-9388-01C8689B8444}"/>
-              </a:ext>
-            </a:extLst>
-          </p:cNvPr>
-          <p:cNvSpPr>
-            <a:spLocks xmlns:a="http://schemas.openxmlformats.org/drawingml/2006/main" noGrp="1"/>
-          </p:cNvSpPr>
-          <p:nvPr/>
-        </p:nvSpPr>
-        <p:spPr>
-          <a:xfrm xmlns:a="http://schemas.openxmlformats.org/drawingml/2006/main">
-            <a:off x="457200" y="600075"/>
-            <a:ext cx="11277600" cy="0"/>
-          </a:xfrm>
-          <a:prstGeom xmlns:a="http://schemas.openxmlformats.org/drawingml/2006/main" prst="line">
-            <a:avLst/>
-          </a:prstGeom>
-          <a:noFill xmlns:a="http://schemas.openxmlformats.org/drawingml/2006/main"/>
-          <a:ln xmlns:a="http://schemas.openxmlformats.org/drawingml/2006/main" w="19050">
-            <a:solidFill>
-              <a:srgbClr val="E9E9E9"/>
-            </a:solidFill>
-            <a:prstDash val="solid"/>
-          </a:ln>
-        </p:spPr>
-      </p:sp>
-      <p:sp>
-        <p:nvSpPr>
-          <p:cNvPr id="3" name="sources-anchor">
-            <a:extLst xmlns:a="http://schemas.openxmlformats.org/drawingml/2006/main">
-              <a:ext uri="{FF2B5EF4-FFF2-40B4-BE49-F238E27FC236}">
-                <a16:creationId xmlns:a16="http://schemas.microsoft.com/office/drawing/2014/main" id="{FC02B011-BA08-4B21-B43A-215EA3C25AC4}"/>
-              </a:ext>
-            </a:extLst>
-          </p:cNvPr>
-          <p:cNvSpPr>
-            <a:spLocks xmlns:a="http://schemas.openxmlformats.org/drawingml/2006/main" noGrp="1"/>
-          </p:cNvSpPr>
-          <p:nvPr/>
-        </p:nvSpPr>
-        <p:spPr>
-          <a:xfrm xmlns:a="http://schemas.openxmlformats.org/drawingml/2006/main">
-            <a:off x="400050" y="1190625"/>
-            <a:ext cx="1504950" cy="1238250"/>
+      </p:sp>
+      <p:sp>
+        <p:nvSpPr>
+          <p:cNvPr id="4" name="clean-anchor">
+            <a:extLst xmlns:a="http://schemas.openxmlformats.org/drawingml/2006/main">
+              <a:ext uri="{FF2B5EF4-FFF2-40B4-BE49-F238E27FC236}">
+                <a16:creationId xmlns:a16="http://schemas.microsoft.com/office/drawing/2014/main" id="{AFB529F5-45E8-46C1-91C2-15065E568006}"/>
+              </a:ext>
+            </a:extLst>
+          </p:cNvPr>
+          <p:cNvSpPr>
+            <a:spLocks xmlns:a="http://schemas.openxmlformats.org/drawingml/2006/main" noGrp="1"/>
+          </p:cNvSpPr>
+          <p:nvPr/>
+        </p:nvSpPr>
+        <p:spPr>
+          <a:xfrm xmlns:a="http://schemas.openxmlformats.org/drawingml/2006/main">
+            <a:off x="2428875" y="1428750"/>
+            <a:ext cx="1952625" cy="742950"/>
           </a:xfrm>
           <a:prstGeom xmlns:a="http://schemas.openxmlformats.org/drawingml/2006/main" prst="rect">
             <a:avLst/>
@@ -1276,21 +1217,21 @@
       </p:sp>
       <p:sp>
         <p:nvSpPr>
-          <p:cNvPr id="4" name="clean-anchor">
-            <a:extLst xmlns:a="http://schemas.openxmlformats.org/drawingml/2006/main">
-              <a:ext uri="{FF2B5EF4-FFF2-40B4-BE49-F238E27FC236}">
-                <a16:creationId xmlns:a16="http://schemas.microsoft.com/office/drawing/2014/main" id="{AFB529F5-45E8-46C1-91C2-15065E568006}"/>
-              </a:ext>
-            </a:extLst>
-          </p:cNvPr>
-          <p:cNvSpPr>
-            <a:spLocks xmlns:a="http://schemas.openxmlformats.org/drawingml/2006/main" noGrp="1"/>
-          </p:cNvSpPr>
-          <p:nvPr/>
-        </p:nvSpPr>
-        <p:spPr>
-          <a:xfrm xmlns:a="http://schemas.openxmlformats.org/drawingml/2006/main">
-            <a:off x="2428875" y="1428750"/>
+          <p:cNvPr id="5" name="integrate-anchor">
+            <a:extLst xmlns:a="http://schemas.openxmlformats.org/drawingml/2006/main">
+              <a:ext uri="{FF2B5EF4-FFF2-40B4-BE49-F238E27FC236}">
+                <a16:creationId xmlns:a16="http://schemas.microsoft.com/office/drawing/2014/main" id="{00526C65-06C6-4205-A152-8B327B27A711}"/>
+              </a:ext>
+            </a:extLst>
+          </p:cNvPr>
+          <p:cNvSpPr>
+            <a:spLocks xmlns:a="http://schemas.openxmlformats.org/drawingml/2006/main" noGrp="1"/>
+          </p:cNvSpPr>
+          <p:nvPr/>
+        </p:nvSpPr>
+        <p:spPr>
+          <a:xfrm xmlns:a="http://schemas.openxmlformats.org/drawingml/2006/main">
+            <a:off x="4810125" y="1428750"/>
             <a:ext cx="1952625" cy="742950"/>
           </a:xfrm>
           <a:prstGeom xmlns:a="http://schemas.openxmlformats.org/drawingml/2006/main" prst="rect">
@@ -1305,21 +1246,21 @@
       </p:sp>
       <p:sp>
         <p:nvSpPr>
-          <p:cNvPr id="5" name="integrate-anchor">
-            <a:extLst xmlns:a="http://schemas.openxmlformats.org/drawingml/2006/main">
-              <a:ext uri="{FF2B5EF4-FFF2-40B4-BE49-F238E27FC236}">
-                <a16:creationId xmlns:a16="http://schemas.microsoft.com/office/drawing/2014/main" id="{00526C65-06C6-4205-A152-8B327B27A711}"/>
-              </a:ext>
-            </a:extLst>
-          </p:cNvPr>
-          <p:cNvSpPr>
-            <a:spLocks xmlns:a="http://schemas.openxmlformats.org/drawingml/2006/main" noGrp="1"/>
-          </p:cNvSpPr>
-          <p:nvPr/>
-        </p:nvSpPr>
-        <p:spPr>
-          <a:xfrm xmlns:a="http://schemas.openxmlformats.org/drawingml/2006/main">
-            <a:off x="4810125" y="1428750"/>
+          <p:cNvPr id="6" name="cases-anchor">
+            <a:extLst xmlns:a="http://schemas.openxmlformats.org/drawingml/2006/main">
+              <a:ext uri="{FF2B5EF4-FFF2-40B4-BE49-F238E27FC236}">
+                <a16:creationId xmlns:a16="http://schemas.microsoft.com/office/drawing/2014/main" id="{7A04ECF8-6099-4A60-AF4B-BD8A480E359D}"/>
+              </a:ext>
+            </a:extLst>
+          </p:cNvPr>
+          <p:cNvSpPr>
+            <a:spLocks xmlns:a="http://schemas.openxmlformats.org/drawingml/2006/main" noGrp="1"/>
+          </p:cNvSpPr>
+          <p:nvPr/>
+        </p:nvSpPr>
+        <p:spPr>
+          <a:xfrm xmlns:a="http://schemas.openxmlformats.org/drawingml/2006/main">
+            <a:off x="7191375" y="1428750"/>
             <a:ext cx="1952625" cy="742950"/>
           </a:xfrm>
           <a:prstGeom xmlns:a="http://schemas.openxmlformats.org/drawingml/2006/main" prst="rect">
@@ -1334,21 +1275,21 @@
       </p:sp>
       <p:sp>
         <p:nvSpPr>
-          <p:cNvPr id="6" name="cases-anchor">
-            <a:extLst xmlns:a="http://schemas.openxmlformats.org/drawingml/2006/main">
-              <a:ext uri="{FF2B5EF4-FFF2-40B4-BE49-F238E27FC236}">
-                <a16:creationId xmlns:a16="http://schemas.microsoft.com/office/drawing/2014/main" id="{7A04ECF8-6099-4A60-AF4B-BD8A480E359D}"/>
-              </a:ext>
-            </a:extLst>
-          </p:cNvPr>
-          <p:cNvSpPr>
-            <a:spLocks xmlns:a="http://schemas.openxmlformats.org/drawingml/2006/main" noGrp="1"/>
-          </p:cNvSpPr>
-          <p:nvPr/>
-        </p:nvSpPr>
-        <p:spPr>
-          <a:xfrm xmlns:a="http://schemas.openxmlformats.org/drawingml/2006/main">
-            <a:off x="7191375" y="1428750"/>
+          <p:cNvPr id="7" name="lifecycle-anchor">
+            <a:extLst xmlns:a="http://schemas.openxmlformats.org/drawingml/2006/main">
+              <a:ext uri="{FF2B5EF4-FFF2-40B4-BE49-F238E27FC236}">
+                <a16:creationId xmlns:a16="http://schemas.microsoft.com/office/drawing/2014/main" id="{A0209A92-03CC-45AF-B7F8-7C3344FF3327}"/>
+              </a:ext>
+            </a:extLst>
+          </p:cNvPr>
+          <p:cNvSpPr>
+            <a:spLocks xmlns:a="http://schemas.openxmlformats.org/drawingml/2006/main" noGrp="1"/>
+          </p:cNvSpPr>
+          <p:nvPr/>
+        </p:nvSpPr>
+        <p:spPr>
+          <a:xfrm xmlns:a="http://schemas.openxmlformats.org/drawingml/2006/main">
+            <a:off x="9572625" y="1428750"/>
             <a:ext cx="1952625" cy="742950"/>
           </a:xfrm>
           <a:prstGeom xmlns:a="http://schemas.openxmlformats.org/drawingml/2006/main" prst="rect">
@@ -1363,21 +1304,21 @@
       </p:sp>
       <p:sp>
         <p:nvSpPr>
-          <p:cNvPr id="7" name="lifecycle-anchor">
-            <a:extLst xmlns:a="http://schemas.openxmlformats.org/drawingml/2006/main">
-              <a:ext uri="{FF2B5EF4-FFF2-40B4-BE49-F238E27FC236}">
-                <a16:creationId xmlns:a16="http://schemas.microsoft.com/office/drawing/2014/main" id="{A0209A92-03CC-45AF-B7F8-7C3344FF3327}"/>
-              </a:ext>
-            </a:extLst>
-          </p:cNvPr>
-          <p:cNvSpPr>
-            <a:spLocks xmlns:a="http://schemas.openxmlformats.org/drawingml/2006/main" noGrp="1"/>
-          </p:cNvSpPr>
-          <p:nvPr/>
-        </p:nvSpPr>
-        <p:spPr>
-          <a:xfrm xmlns:a="http://schemas.openxmlformats.org/drawingml/2006/main">
-            <a:off x="9572625" y="1428750"/>
+          <p:cNvPr id="8" name="context-anchor">
+            <a:extLst xmlns:a="http://schemas.openxmlformats.org/drawingml/2006/main">
+              <a:ext uri="{FF2B5EF4-FFF2-40B4-BE49-F238E27FC236}">
+                <a16:creationId xmlns:a16="http://schemas.microsoft.com/office/drawing/2014/main" id="{187E234F-B701-4E25-9435-949822792040}"/>
+              </a:ext>
+            </a:extLst>
+          </p:cNvPr>
+          <p:cNvSpPr>
+            <a:spLocks xmlns:a="http://schemas.openxmlformats.org/drawingml/2006/main" noGrp="1"/>
+          </p:cNvSpPr>
+          <p:nvPr/>
+        </p:nvSpPr>
+        <p:spPr>
+          <a:xfrm xmlns:a="http://schemas.openxmlformats.org/drawingml/2006/main">
+            <a:off x="9572625" y="4000500"/>
             <a:ext cx="1952625" cy="742950"/>
           </a:xfrm>
           <a:prstGeom xmlns:a="http://schemas.openxmlformats.org/drawingml/2006/main" prst="rect">
@@ -1392,21 +1333,21 @@
       </p:sp>
       <p:sp>
         <p:nvSpPr>
-          <p:cNvPr id="8" name="context-anchor">
-            <a:extLst xmlns:a="http://schemas.openxmlformats.org/drawingml/2006/main">
-              <a:ext uri="{FF2B5EF4-FFF2-40B4-BE49-F238E27FC236}">
-                <a16:creationId xmlns:a16="http://schemas.microsoft.com/office/drawing/2014/main" id="{187E234F-B701-4E25-9435-949822792040}"/>
-              </a:ext>
-            </a:extLst>
-          </p:cNvPr>
-          <p:cNvSpPr>
-            <a:spLocks xmlns:a="http://schemas.openxmlformats.org/drawingml/2006/main" noGrp="1"/>
-          </p:cNvSpPr>
-          <p:nvPr/>
-        </p:nvSpPr>
-        <p:spPr>
-          <a:xfrm xmlns:a="http://schemas.openxmlformats.org/drawingml/2006/main">
-            <a:off x="9572625" y="4000500"/>
+          <p:cNvPr id="9" name="quality-anchor">
+            <a:extLst xmlns:a="http://schemas.openxmlformats.org/drawingml/2006/main">
+              <a:ext uri="{FF2B5EF4-FFF2-40B4-BE49-F238E27FC236}">
+                <a16:creationId xmlns:a16="http://schemas.microsoft.com/office/drawing/2014/main" id="{423BBD31-ED1C-478F-AD57-4A6A190F254D}"/>
+              </a:ext>
+            </a:extLst>
+          </p:cNvPr>
+          <p:cNvSpPr>
+            <a:spLocks xmlns:a="http://schemas.openxmlformats.org/drawingml/2006/main" noGrp="1"/>
+          </p:cNvSpPr>
+          <p:nvPr/>
+        </p:nvSpPr>
+        <p:spPr>
+          <a:xfrm xmlns:a="http://schemas.openxmlformats.org/drawingml/2006/main">
+            <a:off x="7191375" y="4000500"/>
             <a:ext cx="1952625" cy="742950"/>
           </a:xfrm>
           <a:prstGeom xmlns:a="http://schemas.openxmlformats.org/drawingml/2006/main" prst="rect">
@@ -1421,21 +1362,21 @@
       </p:sp>
       <p:sp>
         <p:nvSpPr>
-          <p:cNvPr id="9" name="quality-anchor">
-            <a:extLst xmlns:a="http://schemas.openxmlformats.org/drawingml/2006/main">
-              <a:ext uri="{FF2B5EF4-FFF2-40B4-BE49-F238E27FC236}">
-                <a16:creationId xmlns:a16="http://schemas.microsoft.com/office/drawing/2014/main" id="{423BBD31-ED1C-478F-AD57-4A6A190F254D}"/>
-              </a:ext>
-            </a:extLst>
-          </p:cNvPr>
-          <p:cNvSpPr>
-            <a:spLocks xmlns:a="http://schemas.openxmlformats.org/drawingml/2006/main" noGrp="1"/>
-          </p:cNvSpPr>
-          <p:nvPr/>
-        </p:nvSpPr>
-        <p:spPr>
-          <a:xfrm xmlns:a="http://schemas.openxmlformats.org/drawingml/2006/main">
-            <a:off x="7191375" y="4000500"/>
+          <p:cNvPr id="10" name="export-anchor">
+            <a:extLst xmlns:a="http://schemas.openxmlformats.org/drawingml/2006/main">
+              <a:ext uri="{FF2B5EF4-FFF2-40B4-BE49-F238E27FC236}">
+                <a16:creationId xmlns:a16="http://schemas.microsoft.com/office/drawing/2014/main" id="{FF7C8FF0-25DD-446F-9965-B989DF409B46}"/>
+              </a:ext>
+            </a:extLst>
+          </p:cNvPr>
+          <p:cNvSpPr>
+            <a:spLocks xmlns:a="http://schemas.openxmlformats.org/drawingml/2006/main" noGrp="1"/>
+          </p:cNvSpPr>
+          <p:nvPr/>
+        </p:nvSpPr>
+        <p:spPr>
+          <a:xfrm xmlns:a="http://schemas.openxmlformats.org/drawingml/2006/main">
+            <a:off x="4810125" y="4000500"/>
             <a:ext cx="1952625" cy="742950"/>
           </a:xfrm>
           <a:prstGeom xmlns:a="http://schemas.openxmlformats.org/drawingml/2006/main" prst="rect">
@@ -1450,21 +1391,21 @@
       </p:sp>
       <p:sp>
         <p:nvSpPr>
-          <p:cNvPr id="10" name="export-anchor">
-            <a:extLst xmlns:a="http://schemas.openxmlformats.org/drawingml/2006/main">
-              <a:ext uri="{FF2B5EF4-FFF2-40B4-BE49-F238E27FC236}">
-                <a16:creationId xmlns:a16="http://schemas.microsoft.com/office/drawing/2014/main" id="{FF7C8FF0-25DD-446F-9965-B989DF409B46}"/>
-              </a:ext>
-            </a:extLst>
-          </p:cNvPr>
-          <p:cNvSpPr>
-            <a:spLocks xmlns:a="http://schemas.openxmlformats.org/drawingml/2006/main" noGrp="1"/>
-          </p:cNvSpPr>
-          <p:nvPr/>
-        </p:nvSpPr>
-        <p:spPr>
-          <a:xfrm xmlns:a="http://schemas.openxmlformats.org/drawingml/2006/main">
-            <a:off x="4810125" y="4000500"/>
+          <p:cNvPr id="11" name="output-anchor">
+            <a:extLst xmlns:a="http://schemas.openxmlformats.org/drawingml/2006/main">
+              <a:ext uri="{FF2B5EF4-FFF2-40B4-BE49-F238E27FC236}">
+                <a16:creationId xmlns:a16="http://schemas.microsoft.com/office/drawing/2014/main" id="{DDD45645-634F-4E7C-B090-8DD9864A58B3}"/>
+              </a:ext>
+            </a:extLst>
+          </p:cNvPr>
+          <p:cNvSpPr>
+            <a:spLocks xmlns:a="http://schemas.openxmlformats.org/drawingml/2006/main" noGrp="1"/>
+          </p:cNvSpPr>
+          <p:nvPr/>
+        </p:nvSpPr>
+        <p:spPr>
+          <a:xfrm xmlns:a="http://schemas.openxmlformats.org/drawingml/2006/main">
+            <a:off x="2428875" y="4000500"/>
             <a:ext cx="1952625" cy="742950"/>
           </a:xfrm>
           <a:prstGeom xmlns:a="http://schemas.openxmlformats.org/drawingml/2006/main" prst="rect">
@@ -1477,38 +1418,9 @@
           </a:ln>
         </p:spPr>
       </p:sp>
-      <p:sp>
-        <p:nvSpPr>
-          <p:cNvPr id="11" name="output-anchor">
-            <a:extLst xmlns:a="http://schemas.openxmlformats.org/drawingml/2006/main">
-              <a:ext uri="{FF2B5EF4-FFF2-40B4-BE49-F238E27FC236}">
-                <a16:creationId xmlns:a16="http://schemas.microsoft.com/office/drawing/2014/main" id="{DDD45645-634F-4E7C-B090-8DD9864A58B3}"/>
-              </a:ext>
-            </a:extLst>
-          </p:cNvPr>
-          <p:cNvSpPr>
-            <a:spLocks xmlns:a="http://schemas.openxmlformats.org/drawingml/2006/main" noGrp="1"/>
-          </p:cNvSpPr>
-          <p:nvPr/>
-        </p:nvSpPr>
-        <p:spPr>
-          <a:xfrm xmlns:a="http://schemas.openxmlformats.org/drawingml/2006/main">
-            <a:off x="2428875" y="4000500"/>
-            <a:ext cx="1952625" cy="742950"/>
-          </a:xfrm>
-          <a:prstGeom xmlns:a="http://schemas.openxmlformats.org/drawingml/2006/main" prst="rect">
-            <a:avLst/>
-          </a:prstGeom>
-          <a:noFill xmlns:a="http://schemas.openxmlformats.org/drawingml/2006/main"/>
-          <a:ln xmlns:a="http://schemas.openxmlformats.org/drawingml/2006/main" w="0">
-            <a:noFill/>
-            <a:prstDash val="solid"/>
-          </a:ln>
-        </p:spPr>
-      </p:sp>
       <p:cxnSp>
         <p:nvCxnSpPr>
-          <p:cNvPr id="149" name=""/>
+          <p:cNvPr id="221" name=""/>
           <p:cNvCxnSpPr>
             <a:stCxn xmlns:a="http://schemas.openxmlformats.org/drawingml/2006/main" id="3" idx="3"/>
             <a:endCxn xmlns:a="http://schemas.openxmlformats.org/drawingml/2006/main" id="4" idx="1"/>
@@ -1534,7 +1446,7 @@
       </p:cxnSp>
       <p:cxnSp>
         <p:nvCxnSpPr>
-          <p:cNvPr id="150" name=""/>
+          <p:cNvPr id="222" name=""/>
           <p:cNvCxnSpPr>
             <a:stCxn xmlns:a="http://schemas.openxmlformats.org/drawingml/2006/main" id="4" idx="3"/>
             <a:endCxn xmlns:a="http://schemas.openxmlformats.org/drawingml/2006/main" id="5" idx="1"/>
@@ -1560,7 +1472,7 @@
       </p:cxnSp>
       <p:cxnSp>
         <p:nvCxnSpPr>
-          <p:cNvPr id="151" name=""/>
+          <p:cNvPr id="223" name=""/>
           <p:cNvCxnSpPr>
             <a:stCxn xmlns:a="http://schemas.openxmlformats.org/drawingml/2006/main" id="5" idx="3"/>
             <a:endCxn xmlns:a="http://schemas.openxmlformats.org/drawingml/2006/main" id="6" idx="1"/>
@@ -1586,7 +1498,7 @@
       </p:cxnSp>
       <p:cxnSp>
         <p:nvCxnSpPr>
-          <p:cNvPr id="152" name=""/>
+          <p:cNvPr id="224" name=""/>
           <p:cNvCxnSpPr>
             <a:stCxn xmlns:a="http://schemas.openxmlformats.org/drawingml/2006/main" id="6" idx="3"/>
             <a:endCxn xmlns:a="http://schemas.openxmlformats.org/drawingml/2006/main" id="7" idx="1"/>
@@ -1612,7 +1524,7 @@
       </p:cxnSp>
       <p:cxnSp>
         <p:nvCxnSpPr>
-          <p:cNvPr id="153" name=""/>
+          <p:cNvPr id="225" name=""/>
           <p:cNvCxnSpPr>
             <a:stCxn xmlns:a="http://schemas.openxmlformats.org/drawingml/2006/main" id="7" idx="3"/>
             <a:endCxn xmlns:a="http://schemas.openxmlformats.org/drawingml/2006/main" id="8" idx="3"/>
@@ -1638,7 +1550,7 @@
       </p:cxnSp>
       <p:cxnSp>
         <p:nvCxnSpPr>
-          <p:cNvPr id="154" name=""/>
+          <p:cNvPr id="226" name=""/>
           <p:cNvCxnSpPr>
             <a:stCxn xmlns:a="http://schemas.openxmlformats.org/drawingml/2006/main" id="8" idx="1"/>
             <a:endCxn xmlns:a="http://schemas.openxmlformats.org/drawingml/2006/main" id="9" idx="3"/>
@@ -1664,7 +1576,7 @@
       </p:cxnSp>
       <p:cxnSp>
         <p:nvCxnSpPr>
-          <p:cNvPr id="155" name=""/>
+          <p:cNvPr id="227" name=""/>
           <p:cNvCxnSpPr>
             <a:stCxn xmlns:a="http://schemas.openxmlformats.org/drawingml/2006/main" id="9" idx="1"/>
             <a:endCxn xmlns:a="http://schemas.openxmlformats.org/drawingml/2006/main" id="10" idx="3"/>
@@ -1690,7 +1602,7 @@
       </p:cxnSp>
       <p:cxnSp>
         <p:nvCxnSpPr>
-          <p:cNvPr id="156" name=""/>
+          <p:cNvPr id="228" name=""/>
           <p:cNvCxnSpPr>
             <a:stCxn xmlns:a="http://schemas.openxmlformats.org/drawingml/2006/main" id="10" idx="1"/>
             <a:endCxn xmlns:a="http://schemas.openxmlformats.org/drawingml/2006/main" id="11" idx="3"/>
@@ -3156,22 +3068,22 @@
       </p:grpSpPr>
       <p:sp>
         <p:nvSpPr>
-          <p:cNvPr id="55" name="experiments-and-evaluation-label">
-            <a:extLst xmlns:a="http://schemas.openxmlformats.org/drawingml/2006/main">
-              <a:ext uri="{FF2B5EF4-FFF2-40B4-BE49-F238E27FC236}">
-                <a16:creationId xmlns:a16="http://schemas.microsoft.com/office/drawing/2014/main" id="{74B91258-B0D1-4247-872D-2189F99BE55B}"/>
-              </a:ext>
-            </a:extLst>
-          </p:cNvPr>
-          <p:cNvSpPr>
-            <a:spLocks xmlns:a="http://schemas.openxmlformats.org/drawingml/2006/main" noGrp="1"/>
-          </p:cNvSpPr>
-          <p:nvPr/>
-        </p:nvSpPr>
-        <p:spPr>
-          <a:xfrm xmlns:a="http://schemas.openxmlformats.org/drawingml/2006/main">
-            <a:off x="457200" y="266700"/>
-            <a:ext cx="3714750" cy="266700"/>
+          <p:cNvPr id="3" name="input-anchor">
+            <a:extLst xmlns:a="http://schemas.openxmlformats.org/drawingml/2006/main">
+              <a:ext uri="{FF2B5EF4-FFF2-40B4-BE49-F238E27FC236}">
+                <a16:creationId xmlns:a16="http://schemas.microsoft.com/office/drawing/2014/main" id="{10937771-3A3B-4ECF-986D-5348F3D1D221}"/>
+              </a:ext>
+            </a:extLst>
+          </p:cNvPr>
+          <p:cNvSpPr>
+            <a:spLocks xmlns:a="http://schemas.openxmlformats.org/drawingml/2006/main" noGrp="1"/>
+          </p:cNvSpPr>
+          <p:nvPr/>
+        </p:nvSpPr>
+        <p:spPr>
+          <a:xfrm xmlns:a="http://schemas.openxmlformats.org/drawingml/2006/main">
+            <a:off x="400050" y="1143000"/>
+            <a:ext cx="1619250" cy="704850"/>
           </a:xfrm>
           <a:prstGeom xmlns:a="http://schemas.openxmlformats.org/drawingml/2006/main" prst="rect">
             <a:avLst/>
@@ -3182,84 +3094,25 @@
             <a:prstDash val="solid"/>
           </a:ln>
         </p:spPr>
-        <p:txBody>
-          <a:bodyPr xmlns:a="http://schemas.openxmlformats.org/drawingml/2006/main" anchor="ctr"/>
-          <a:lstStyle xmlns:a="http://schemas.openxmlformats.org/drawingml/2006/main"/>
-          <a:p xmlns:a="http://schemas.openxmlformats.org/drawingml/2006/main">
-            <a:pPr algn="l">
-              <a:buNone/>
-              <a:defRPr sz="1500" b="1">
-                <a:solidFill>
-                  <a:srgbClr val="5D5D5D"/>
-                </a:solidFill>
-                <a:latin typeface="Arial"/>
-                <a:ea typeface="Arial"/>
-                <a:cs typeface="Arial"/>
-              </a:defRPr>
-            </a:pPr>
-            <a:r>
-              <a:rPr sz="1500" b="1">
-                <a:solidFill>
-                  <a:srgbClr val="5D5D5D"/>
-                </a:solidFill>
-                <a:latin typeface="Arial"/>
-                <a:ea typeface="Arial"/>
-                <a:cs typeface="Arial"/>
-              </a:rPr>
-              <a:t>EXPERIMENTS AND EVALUATION</a:t>
-            </a:r>
-          </a:p>
-        </p:txBody>
-      </p:sp>
-      <p:sp>
-        <p:nvSpPr>
-          <p:cNvPr id="2" name="experiments-and-evaluation-rule">
-            <a:extLst xmlns:a="http://schemas.openxmlformats.org/drawingml/2006/main">
-              <a:ext uri="{FF2B5EF4-FFF2-40B4-BE49-F238E27FC236}">
-                <a16:creationId xmlns:a16="http://schemas.microsoft.com/office/drawing/2014/main" id="{A312B594-2D4F-48C1-B069-CDE536140E31}"/>
-              </a:ext>
-            </a:extLst>
-          </p:cNvPr>
-          <p:cNvSpPr>
-            <a:spLocks xmlns:a="http://schemas.openxmlformats.org/drawingml/2006/main" noGrp="1"/>
-          </p:cNvSpPr>
-          <p:nvPr/>
-        </p:nvSpPr>
-        <p:spPr>
-          <a:xfrm xmlns:a="http://schemas.openxmlformats.org/drawingml/2006/main">
-            <a:off x="457200" y="600075"/>
-            <a:ext cx="11277600" cy="0"/>
-          </a:xfrm>
-          <a:prstGeom xmlns:a="http://schemas.openxmlformats.org/drawingml/2006/main" prst="line">
-            <a:avLst/>
-          </a:prstGeom>
-          <a:noFill xmlns:a="http://schemas.openxmlformats.org/drawingml/2006/main"/>
-          <a:ln xmlns:a="http://schemas.openxmlformats.org/drawingml/2006/main" w="19050">
-            <a:solidFill>
-              <a:srgbClr val="E9E9E9"/>
-            </a:solidFill>
-            <a:prstDash val="solid"/>
-          </a:ln>
-        </p:spPr>
-      </p:sp>
-      <p:sp>
-        <p:nvSpPr>
-          <p:cNvPr id="3" name="input-anchor">
-            <a:extLst xmlns:a="http://schemas.openxmlformats.org/drawingml/2006/main">
-              <a:ext uri="{FF2B5EF4-FFF2-40B4-BE49-F238E27FC236}">
-                <a16:creationId xmlns:a16="http://schemas.microsoft.com/office/drawing/2014/main" id="{10937771-3A3B-4ECF-986D-5348F3D1D221}"/>
-              </a:ext>
-            </a:extLst>
-          </p:cNvPr>
-          <p:cNvSpPr>
-            <a:spLocks xmlns:a="http://schemas.openxmlformats.org/drawingml/2006/main" noGrp="1"/>
-          </p:cNvSpPr>
-          <p:nvPr/>
-        </p:nvSpPr>
-        <p:spPr>
-          <a:xfrm xmlns:a="http://schemas.openxmlformats.org/drawingml/2006/main">
-            <a:off x="400050" y="1143000"/>
-            <a:ext cx="1619250" cy="704850"/>
+      </p:sp>
+      <p:sp>
+        <p:nvSpPr>
+          <p:cNvPr id="4" name="split-anchor">
+            <a:extLst xmlns:a="http://schemas.openxmlformats.org/drawingml/2006/main">
+              <a:ext uri="{FF2B5EF4-FFF2-40B4-BE49-F238E27FC236}">
+                <a16:creationId xmlns:a16="http://schemas.microsoft.com/office/drawing/2014/main" id="{8712BDD9-3F1D-4028-B173-2CA64225E59E}"/>
+              </a:ext>
+            </a:extLst>
+          </p:cNvPr>
+          <p:cNvSpPr>
+            <a:spLocks xmlns:a="http://schemas.openxmlformats.org/drawingml/2006/main" noGrp="1"/>
+          </p:cNvSpPr>
+          <p:nvPr/>
+        </p:nvSpPr>
+        <p:spPr>
+          <a:xfrm xmlns:a="http://schemas.openxmlformats.org/drawingml/2006/main">
+            <a:off x="2571750" y="1143000"/>
+            <a:ext cx="1714500" cy="704850"/>
           </a:xfrm>
           <a:prstGeom xmlns:a="http://schemas.openxmlformats.org/drawingml/2006/main" prst="rect">
             <a:avLst/>
@@ -3273,21 +3126,21 @@
       </p:sp>
       <p:sp>
         <p:nvSpPr>
-          <p:cNvPr id="4" name="split-anchor">
-            <a:extLst xmlns:a="http://schemas.openxmlformats.org/drawingml/2006/main">
-              <a:ext uri="{FF2B5EF4-FFF2-40B4-BE49-F238E27FC236}">
-                <a16:creationId xmlns:a16="http://schemas.microsoft.com/office/drawing/2014/main" id="{8712BDD9-3F1D-4028-B173-2CA64225E59E}"/>
-              </a:ext>
-            </a:extLst>
-          </p:cNvPr>
-          <p:cNvSpPr>
-            <a:spLocks xmlns:a="http://schemas.openxmlformats.org/drawingml/2006/main" noGrp="1"/>
-          </p:cNvSpPr>
-          <p:nvPr/>
-        </p:nvSpPr>
-        <p:spPr>
-          <a:xfrm xmlns:a="http://schemas.openxmlformats.org/drawingml/2006/main">
-            <a:off x="2571750" y="1143000"/>
+          <p:cNvPr id="5" name="miner-anchor">
+            <a:extLst xmlns:a="http://schemas.openxmlformats.org/drawingml/2006/main">
+              <a:ext uri="{FF2B5EF4-FFF2-40B4-BE49-F238E27FC236}">
+                <a16:creationId xmlns:a16="http://schemas.microsoft.com/office/drawing/2014/main" id="{F673B1BF-C8BE-4922-B188-52CC608BC528}"/>
+              </a:ext>
+            </a:extLst>
+          </p:cNvPr>
+          <p:cNvSpPr>
+            <a:spLocks xmlns:a="http://schemas.openxmlformats.org/drawingml/2006/main" noGrp="1"/>
+          </p:cNvSpPr>
+          <p:nvPr/>
+        </p:nvSpPr>
+        <p:spPr>
+          <a:xfrm xmlns:a="http://schemas.openxmlformats.org/drawingml/2006/main">
+            <a:off x="4810125" y="1143000"/>
             <a:ext cx="1714500" cy="704850"/>
           </a:xfrm>
           <a:prstGeom xmlns:a="http://schemas.openxmlformats.org/drawingml/2006/main" prst="rect">
@@ -3302,21 +3155,21 @@
       </p:sp>
       <p:sp>
         <p:nvSpPr>
-          <p:cNvPr id="5" name="miner-anchor">
-            <a:extLst xmlns:a="http://schemas.openxmlformats.org/drawingml/2006/main">
-              <a:ext uri="{FF2B5EF4-FFF2-40B4-BE49-F238E27FC236}">
-                <a16:creationId xmlns:a16="http://schemas.microsoft.com/office/drawing/2014/main" id="{F673B1BF-C8BE-4922-B188-52CC608BC528}"/>
-              </a:ext>
-            </a:extLst>
-          </p:cNvPr>
-          <p:cNvSpPr>
-            <a:spLocks xmlns:a="http://schemas.openxmlformats.org/drawingml/2006/main" noGrp="1"/>
-          </p:cNvSpPr>
-          <p:nvPr/>
-        </p:nvSpPr>
-        <p:spPr>
-          <a:xfrm xmlns:a="http://schemas.openxmlformats.org/drawingml/2006/main">
-            <a:off x="4810125" y="1143000"/>
+          <p:cNvPr id="6" name="audit-anchor">
+            <a:extLst xmlns:a="http://schemas.openxmlformats.org/drawingml/2006/main">
+              <a:ext uri="{FF2B5EF4-FFF2-40B4-BE49-F238E27FC236}">
+                <a16:creationId xmlns:a16="http://schemas.microsoft.com/office/drawing/2014/main" id="{63FEADAC-3FA5-4CAA-B135-84ABACF6164A}"/>
+              </a:ext>
+            </a:extLst>
+          </p:cNvPr>
+          <p:cNvSpPr>
+            <a:spLocks xmlns:a="http://schemas.openxmlformats.org/drawingml/2006/main" noGrp="1"/>
+          </p:cNvSpPr>
+          <p:nvPr/>
+        </p:nvSpPr>
+        <p:spPr>
+          <a:xfrm xmlns:a="http://schemas.openxmlformats.org/drawingml/2006/main">
+            <a:off x="7048500" y="1143000"/>
             <a:ext cx="1714500" cy="704850"/>
           </a:xfrm>
           <a:prstGeom xmlns:a="http://schemas.openxmlformats.org/drawingml/2006/main" prst="rect">
@@ -3331,22 +3184,22 @@
       </p:sp>
       <p:sp>
         <p:nvSpPr>
-          <p:cNvPr id="6" name="audit-anchor">
-            <a:extLst xmlns:a="http://schemas.openxmlformats.org/drawingml/2006/main">
-              <a:ext uri="{FF2B5EF4-FFF2-40B4-BE49-F238E27FC236}">
-                <a16:creationId xmlns:a16="http://schemas.microsoft.com/office/drawing/2014/main" id="{63FEADAC-3FA5-4CAA-B135-84ABACF6164A}"/>
-              </a:ext>
-            </a:extLst>
-          </p:cNvPr>
-          <p:cNvSpPr>
-            <a:spLocks xmlns:a="http://schemas.openxmlformats.org/drawingml/2006/main" noGrp="1"/>
-          </p:cNvSpPr>
-          <p:nvPr/>
-        </p:nvSpPr>
-        <p:spPr>
-          <a:xfrm xmlns:a="http://schemas.openxmlformats.org/drawingml/2006/main">
-            <a:off x="7048500" y="1143000"/>
-            <a:ext cx="1714500" cy="704850"/>
+          <p:cNvPr id="7" name="trie-anchor">
+            <a:extLst xmlns:a="http://schemas.openxmlformats.org/drawingml/2006/main">
+              <a:ext uri="{FF2B5EF4-FFF2-40B4-BE49-F238E27FC236}">
+                <a16:creationId xmlns:a16="http://schemas.microsoft.com/office/drawing/2014/main" id="{AA222AE1-8CD1-4E70-B614-B5CA1E8CCAC1}"/>
+              </a:ext>
+            </a:extLst>
+          </p:cNvPr>
+          <p:cNvSpPr>
+            <a:spLocks xmlns:a="http://schemas.openxmlformats.org/drawingml/2006/main" noGrp="1"/>
+          </p:cNvSpPr>
+          <p:nvPr/>
+        </p:nvSpPr>
+        <p:spPr>
+          <a:xfrm xmlns:a="http://schemas.openxmlformats.org/drawingml/2006/main">
+            <a:off x="9286875" y="1143000"/>
+            <a:ext cx="2190750" cy="704850"/>
           </a:xfrm>
           <a:prstGeom xmlns:a="http://schemas.openxmlformats.org/drawingml/2006/main" prst="rect">
             <a:avLst/>
@@ -3360,21 +3213,21 @@
       </p:sp>
       <p:sp>
         <p:nvSpPr>
-          <p:cNvPr id="7" name="trie-anchor">
-            <a:extLst xmlns:a="http://schemas.openxmlformats.org/drawingml/2006/main">
-              <a:ext uri="{FF2B5EF4-FFF2-40B4-BE49-F238E27FC236}">
-                <a16:creationId xmlns:a16="http://schemas.microsoft.com/office/drawing/2014/main" id="{AA222AE1-8CD1-4E70-B614-B5CA1E8CCAC1}"/>
-              </a:ext>
-            </a:extLst>
-          </p:cNvPr>
-          <p:cNvSpPr>
-            <a:spLocks xmlns:a="http://schemas.openxmlformats.org/drawingml/2006/main" noGrp="1"/>
-          </p:cNvSpPr>
-          <p:nvPr/>
-        </p:nvSpPr>
-        <p:spPr>
-          <a:xfrm xmlns:a="http://schemas.openxmlformats.org/drawingml/2006/main">
-            <a:off x="9286875" y="1143000"/>
+          <p:cNvPr id="8" name="prosit-anchor">
+            <a:extLst xmlns:a="http://schemas.openxmlformats.org/drawingml/2006/main">
+              <a:ext uri="{FF2B5EF4-FFF2-40B4-BE49-F238E27FC236}">
+                <a16:creationId xmlns:a16="http://schemas.microsoft.com/office/drawing/2014/main" id="{58258672-523D-4465-92E6-2CAD2BF3520B}"/>
+              </a:ext>
+            </a:extLst>
+          </p:cNvPr>
+          <p:cNvSpPr>
+            <a:spLocks xmlns:a="http://schemas.openxmlformats.org/drawingml/2006/main" noGrp="1"/>
+          </p:cNvSpPr>
+          <p:nvPr/>
+        </p:nvSpPr>
+        <p:spPr>
+          <a:xfrm xmlns:a="http://schemas.openxmlformats.org/drawingml/2006/main">
+            <a:off x="9286875" y="3095625"/>
             <a:ext cx="2190750" cy="704850"/>
           </a:xfrm>
           <a:prstGeom xmlns:a="http://schemas.openxmlformats.org/drawingml/2006/main" prst="rect">
@@ -3389,22 +3242,22 @@
       </p:sp>
       <p:sp>
         <p:nvSpPr>
-          <p:cNvPr id="8" name="prosit-anchor">
-            <a:extLst xmlns:a="http://schemas.openxmlformats.org/drawingml/2006/main">
-              <a:ext uri="{FF2B5EF4-FFF2-40B4-BE49-F238E27FC236}">
-                <a16:creationId xmlns:a16="http://schemas.microsoft.com/office/drawing/2014/main" id="{58258672-523D-4465-92E6-2CAD2BF3520B}"/>
-              </a:ext>
-            </a:extLst>
-          </p:cNvPr>
-          <p:cNvSpPr>
-            <a:spLocks xmlns:a="http://schemas.openxmlformats.org/drawingml/2006/main" noGrp="1"/>
-          </p:cNvSpPr>
-          <p:nvPr/>
-        </p:nvSpPr>
-        <p:spPr>
-          <a:xfrm xmlns:a="http://schemas.openxmlformats.org/drawingml/2006/main">
-            <a:off x="9286875" y="3095625"/>
-            <a:ext cx="2190750" cy="704850"/>
+          <p:cNvPr id="9" name="freeze-anchor">
+            <a:extLst xmlns:a="http://schemas.openxmlformats.org/drawingml/2006/main">
+              <a:ext uri="{FF2B5EF4-FFF2-40B4-BE49-F238E27FC236}">
+                <a16:creationId xmlns:a16="http://schemas.microsoft.com/office/drawing/2014/main" id="{C526C1C7-E5C7-476C-8D15-FE45BAAA54AC}"/>
+              </a:ext>
+            </a:extLst>
+          </p:cNvPr>
+          <p:cNvSpPr>
+            <a:spLocks xmlns:a="http://schemas.openxmlformats.org/drawingml/2006/main" noGrp="1"/>
+          </p:cNvSpPr>
+          <p:nvPr/>
+        </p:nvSpPr>
+        <p:spPr>
+          <a:xfrm xmlns:a="http://schemas.openxmlformats.org/drawingml/2006/main">
+            <a:off x="7048500" y="3095625"/>
+            <a:ext cx="1714500" cy="704850"/>
           </a:xfrm>
           <a:prstGeom xmlns:a="http://schemas.openxmlformats.org/drawingml/2006/main" prst="rect">
             <a:avLst/>
@@ -3418,21 +3271,21 @@
       </p:sp>
       <p:sp>
         <p:nvSpPr>
-          <p:cNvPr id="9" name="freeze-anchor">
-            <a:extLst xmlns:a="http://schemas.openxmlformats.org/drawingml/2006/main">
-              <a:ext uri="{FF2B5EF4-FFF2-40B4-BE49-F238E27FC236}">
-                <a16:creationId xmlns:a16="http://schemas.microsoft.com/office/drawing/2014/main" id="{C526C1C7-E5C7-476C-8D15-FE45BAAA54AC}"/>
-              </a:ext>
-            </a:extLst>
-          </p:cNvPr>
-          <p:cNvSpPr>
-            <a:spLocks xmlns:a="http://schemas.openxmlformats.org/drawingml/2006/main" noGrp="1"/>
-          </p:cNvSpPr>
-          <p:nvPr/>
-        </p:nvSpPr>
-        <p:spPr>
-          <a:xfrm xmlns:a="http://schemas.openxmlformats.org/drawingml/2006/main">
-            <a:off x="7048500" y="3095625"/>
+          <p:cNvPr id="10" name="simulate-anchor">
+            <a:extLst xmlns:a="http://schemas.openxmlformats.org/drawingml/2006/main">
+              <a:ext uri="{FF2B5EF4-FFF2-40B4-BE49-F238E27FC236}">
+                <a16:creationId xmlns:a16="http://schemas.microsoft.com/office/drawing/2014/main" id="{2AAAFFB3-D2BA-42F4-898E-F94B33E8799F}"/>
+              </a:ext>
+            </a:extLst>
+          </p:cNvPr>
+          <p:cNvSpPr>
+            <a:spLocks xmlns:a="http://schemas.openxmlformats.org/drawingml/2006/main" noGrp="1"/>
+          </p:cNvSpPr>
+          <p:nvPr/>
+        </p:nvSpPr>
+        <p:spPr>
+          <a:xfrm xmlns:a="http://schemas.openxmlformats.org/drawingml/2006/main">
+            <a:off x="4810125" y="3095625"/>
             <a:ext cx="1714500" cy="704850"/>
           </a:xfrm>
           <a:prstGeom xmlns:a="http://schemas.openxmlformats.org/drawingml/2006/main" prst="rect">
@@ -3447,21 +3300,21 @@
       </p:sp>
       <p:sp>
         <p:nvSpPr>
-          <p:cNvPr id="10" name="simulate-anchor">
-            <a:extLst xmlns:a="http://schemas.openxmlformats.org/drawingml/2006/main">
-              <a:ext uri="{FF2B5EF4-FFF2-40B4-BE49-F238E27FC236}">
-                <a16:creationId xmlns:a16="http://schemas.microsoft.com/office/drawing/2014/main" id="{2AAAFFB3-D2BA-42F4-898E-F94B33E8799F}"/>
-              </a:ext>
-            </a:extLst>
-          </p:cNvPr>
-          <p:cNvSpPr>
-            <a:spLocks xmlns:a="http://schemas.openxmlformats.org/drawingml/2006/main" noGrp="1"/>
-          </p:cNvSpPr>
-          <p:nvPr/>
-        </p:nvSpPr>
-        <p:spPr>
-          <a:xfrm xmlns:a="http://schemas.openxmlformats.org/drawingml/2006/main">
-            <a:off x="4810125" y="3095625"/>
+          <p:cNvPr id="11" name="evaluate-anchor">
+            <a:extLst xmlns:a="http://schemas.openxmlformats.org/drawingml/2006/main">
+              <a:ext uri="{FF2B5EF4-FFF2-40B4-BE49-F238E27FC236}">
+                <a16:creationId xmlns:a16="http://schemas.microsoft.com/office/drawing/2014/main" id="{25882D80-35E9-4A61-975F-9A3E24AD55CA}"/>
+              </a:ext>
+            </a:extLst>
+          </p:cNvPr>
+          <p:cNvSpPr>
+            <a:spLocks xmlns:a="http://schemas.openxmlformats.org/drawingml/2006/main" noGrp="1"/>
+          </p:cNvSpPr>
+          <p:nvPr/>
+        </p:nvSpPr>
+        <p:spPr>
+          <a:xfrm xmlns:a="http://schemas.openxmlformats.org/drawingml/2006/main">
+            <a:off x="2571750" y="3095625"/>
             <a:ext cx="1714500" cy="704850"/>
           </a:xfrm>
           <a:prstGeom xmlns:a="http://schemas.openxmlformats.org/drawingml/2006/main" prst="rect">
@@ -3476,22 +3329,22 @@
       </p:sp>
       <p:sp>
         <p:nvSpPr>
-          <p:cNvPr id="11" name="evaluate-anchor">
-            <a:extLst xmlns:a="http://schemas.openxmlformats.org/drawingml/2006/main">
-              <a:ext uri="{FF2B5EF4-FFF2-40B4-BE49-F238E27FC236}">
-                <a16:creationId xmlns:a16="http://schemas.microsoft.com/office/drawing/2014/main" id="{25882D80-35E9-4A61-975F-9A3E24AD55CA}"/>
-              </a:ext>
-            </a:extLst>
-          </p:cNvPr>
-          <p:cNvSpPr>
-            <a:spLocks xmlns:a="http://schemas.openxmlformats.org/drawingml/2006/main" noGrp="1"/>
-          </p:cNvSpPr>
-          <p:nvPr/>
-        </p:nvSpPr>
-        <p:spPr>
-          <a:xfrm xmlns:a="http://schemas.openxmlformats.org/drawingml/2006/main">
-            <a:off x="2571750" y="3095625"/>
-            <a:ext cx="1714500" cy="704850"/>
+          <p:cNvPr id="12" name="sensitivity-anchor">
+            <a:extLst xmlns:a="http://schemas.openxmlformats.org/drawingml/2006/main">
+              <a:ext uri="{FF2B5EF4-FFF2-40B4-BE49-F238E27FC236}">
+                <a16:creationId xmlns:a16="http://schemas.microsoft.com/office/drawing/2014/main" id="{9598AE8E-FFA8-4786-90E2-121D76D77714}"/>
+              </a:ext>
+            </a:extLst>
+          </p:cNvPr>
+          <p:cNvSpPr>
+            <a:spLocks xmlns:a="http://schemas.openxmlformats.org/drawingml/2006/main" noGrp="1"/>
+          </p:cNvSpPr>
+          <p:nvPr/>
+        </p:nvSpPr>
+        <p:spPr>
+          <a:xfrm xmlns:a="http://schemas.openxmlformats.org/drawingml/2006/main">
+            <a:off x="2571750" y="5095875"/>
+            <a:ext cx="2095500" cy="704850"/>
           </a:xfrm>
           <a:prstGeom xmlns:a="http://schemas.openxmlformats.org/drawingml/2006/main" prst="rect">
             <a:avLst/>
@@ -3505,21 +3358,21 @@
       </p:sp>
       <p:sp>
         <p:nvSpPr>
-          <p:cNvPr id="12" name="sensitivity-anchor">
-            <a:extLst xmlns:a="http://schemas.openxmlformats.org/drawingml/2006/main">
-              <a:ext uri="{FF2B5EF4-FFF2-40B4-BE49-F238E27FC236}">
-                <a16:creationId xmlns:a16="http://schemas.microsoft.com/office/drawing/2014/main" id="{9598AE8E-FFA8-4786-90E2-121D76D77714}"/>
-              </a:ext>
-            </a:extLst>
-          </p:cNvPr>
-          <p:cNvSpPr>
-            <a:spLocks xmlns:a="http://schemas.openxmlformats.org/drawingml/2006/main" noGrp="1"/>
-          </p:cNvSpPr>
-          <p:nvPr/>
-        </p:nvSpPr>
-        <p:spPr>
-          <a:xfrm xmlns:a="http://schemas.openxmlformats.org/drawingml/2006/main">
-            <a:off x="2571750" y="5095875"/>
+          <p:cNvPr id="13" name="scenarios-anchor">
+            <a:extLst xmlns:a="http://schemas.openxmlformats.org/drawingml/2006/main">
+              <a:ext uri="{FF2B5EF4-FFF2-40B4-BE49-F238E27FC236}">
+                <a16:creationId xmlns:a16="http://schemas.microsoft.com/office/drawing/2014/main" id="{B8EB5FB1-1DD1-4E96-852B-846ECC872615}"/>
+              </a:ext>
+            </a:extLst>
+          </p:cNvPr>
+          <p:cNvSpPr>
+            <a:spLocks xmlns:a="http://schemas.openxmlformats.org/drawingml/2006/main" noGrp="1"/>
+          </p:cNvSpPr>
+          <p:nvPr/>
+        </p:nvSpPr>
+        <p:spPr>
+          <a:xfrm xmlns:a="http://schemas.openxmlformats.org/drawingml/2006/main">
+            <a:off x="5286375" y="5095875"/>
             <a:ext cx="2095500" cy="704850"/>
           </a:xfrm>
           <a:prstGeom xmlns:a="http://schemas.openxmlformats.org/drawingml/2006/main" prst="rect">
@@ -3534,22 +3387,22 @@
       </p:sp>
       <p:sp>
         <p:nvSpPr>
-          <p:cNvPr id="13" name="scenarios-anchor">
-            <a:extLst xmlns:a="http://schemas.openxmlformats.org/drawingml/2006/main">
-              <a:ext uri="{FF2B5EF4-FFF2-40B4-BE49-F238E27FC236}">
-                <a16:creationId xmlns:a16="http://schemas.microsoft.com/office/drawing/2014/main" id="{B8EB5FB1-1DD1-4E96-852B-846ECC872615}"/>
-              </a:ext>
-            </a:extLst>
-          </p:cNvPr>
-          <p:cNvSpPr>
-            <a:spLocks xmlns:a="http://schemas.openxmlformats.org/drawingml/2006/main" noGrp="1"/>
-          </p:cNvSpPr>
-          <p:nvPr/>
-        </p:nvSpPr>
-        <p:spPr>
-          <a:xfrm xmlns:a="http://schemas.openxmlformats.org/drawingml/2006/main">
-            <a:off x="5286375" y="5095875"/>
-            <a:ext cx="2095500" cy="704850"/>
+          <p:cNvPr id="14" name="interpret-anchor">
+            <a:extLst xmlns:a="http://schemas.openxmlformats.org/drawingml/2006/main">
+              <a:ext uri="{FF2B5EF4-FFF2-40B4-BE49-F238E27FC236}">
+                <a16:creationId xmlns:a16="http://schemas.microsoft.com/office/drawing/2014/main" id="{C9F334EB-08DD-498C-9E2A-5B0D588B4DB1}"/>
+              </a:ext>
+            </a:extLst>
+          </p:cNvPr>
+          <p:cNvSpPr>
+            <a:spLocks xmlns:a="http://schemas.openxmlformats.org/drawingml/2006/main" noGrp="1"/>
+          </p:cNvSpPr>
+          <p:nvPr/>
+        </p:nvSpPr>
+        <p:spPr>
+          <a:xfrm xmlns:a="http://schemas.openxmlformats.org/drawingml/2006/main">
+            <a:off x="8001000" y="5095875"/>
+            <a:ext cx="2857500" cy="704850"/>
           </a:xfrm>
           <a:prstGeom xmlns:a="http://schemas.openxmlformats.org/drawingml/2006/main" prst="rect">
             <a:avLst/>
@@ -3561,38 +3414,9 @@
           </a:ln>
         </p:spPr>
       </p:sp>
-      <p:sp>
-        <p:nvSpPr>
-          <p:cNvPr id="14" name="interpret-anchor">
-            <a:extLst xmlns:a="http://schemas.openxmlformats.org/drawingml/2006/main">
-              <a:ext uri="{FF2B5EF4-FFF2-40B4-BE49-F238E27FC236}">
-                <a16:creationId xmlns:a16="http://schemas.microsoft.com/office/drawing/2014/main" id="{C9F334EB-08DD-498C-9E2A-5B0D588B4DB1}"/>
-              </a:ext>
-            </a:extLst>
-          </p:cNvPr>
-          <p:cNvSpPr>
-            <a:spLocks xmlns:a="http://schemas.openxmlformats.org/drawingml/2006/main" noGrp="1"/>
-          </p:cNvSpPr>
-          <p:nvPr/>
-        </p:nvSpPr>
-        <p:spPr>
-          <a:xfrm xmlns:a="http://schemas.openxmlformats.org/drawingml/2006/main">
-            <a:off x="8001000" y="5095875"/>
-            <a:ext cx="2857500" cy="704850"/>
-          </a:xfrm>
-          <a:prstGeom xmlns:a="http://schemas.openxmlformats.org/drawingml/2006/main" prst="rect">
-            <a:avLst/>
-          </a:prstGeom>
-          <a:noFill xmlns:a="http://schemas.openxmlformats.org/drawingml/2006/main"/>
-          <a:ln xmlns:a="http://schemas.openxmlformats.org/drawingml/2006/main" w="0">
-            <a:noFill/>
-            <a:prstDash val="solid"/>
-          </a:ln>
-        </p:spPr>
-      </p:sp>
       <p:cxnSp>
         <p:nvCxnSpPr>
-          <p:cNvPr id="194" name=""/>
+          <p:cNvPr id="290" name=""/>
           <p:cNvCxnSpPr>
             <a:stCxn xmlns:a="http://schemas.openxmlformats.org/drawingml/2006/main" id="3" idx="3"/>
             <a:endCxn xmlns:a="http://schemas.openxmlformats.org/drawingml/2006/main" id="4" idx="1"/>
@@ -3618,7 +3442,7 @@
       </p:cxnSp>
       <p:cxnSp>
         <p:nvCxnSpPr>
-          <p:cNvPr id="195" name=""/>
+          <p:cNvPr id="291" name=""/>
           <p:cNvCxnSpPr>
             <a:stCxn xmlns:a="http://schemas.openxmlformats.org/drawingml/2006/main" id="4" idx="3"/>
             <a:endCxn xmlns:a="http://schemas.openxmlformats.org/drawingml/2006/main" id="5" idx="1"/>
@@ -3644,7 +3468,7 @@
       </p:cxnSp>
       <p:cxnSp>
         <p:nvCxnSpPr>
-          <p:cNvPr id="196" name=""/>
+          <p:cNvPr id="292" name=""/>
           <p:cNvCxnSpPr>
             <a:stCxn xmlns:a="http://schemas.openxmlformats.org/drawingml/2006/main" id="5" idx="3"/>
             <a:endCxn xmlns:a="http://schemas.openxmlformats.org/drawingml/2006/main" id="6" idx="1"/>
@@ -3670,7 +3494,7 @@
       </p:cxnSp>
       <p:cxnSp>
         <p:nvCxnSpPr>
-          <p:cNvPr id="197" name=""/>
+          <p:cNvPr id="293" name=""/>
           <p:cNvCxnSpPr>
             <a:stCxn xmlns:a="http://schemas.openxmlformats.org/drawingml/2006/main" id="6" idx="3"/>
             <a:endCxn xmlns:a="http://schemas.openxmlformats.org/drawingml/2006/main" id="7" idx="1"/>
@@ -3696,7 +3520,7 @@
       </p:cxnSp>
       <p:cxnSp>
         <p:nvCxnSpPr>
-          <p:cNvPr id="198" name=""/>
+          <p:cNvPr id="294" name=""/>
           <p:cNvCxnSpPr>
             <a:stCxn xmlns:a="http://schemas.openxmlformats.org/drawingml/2006/main" id="7" idx="3"/>
             <a:endCxn xmlns:a="http://schemas.openxmlformats.org/drawingml/2006/main" id="8" idx="3"/>
@@ -3722,7 +3546,7 @@
       </p:cxnSp>
       <p:cxnSp>
         <p:nvCxnSpPr>
-          <p:cNvPr id="199" name=""/>
+          <p:cNvPr id="295" name=""/>
           <p:cNvCxnSpPr>
             <a:stCxn xmlns:a="http://schemas.openxmlformats.org/drawingml/2006/main" id="8" idx="1"/>
             <a:endCxn xmlns:a="http://schemas.openxmlformats.org/drawingml/2006/main" id="9" idx="3"/>
@@ -3748,7 +3572,7 @@
       </p:cxnSp>
       <p:cxnSp>
         <p:nvCxnSpPr>
-          <p:cNvPr id="200" name=""/>
+          <p:cNvPr id="296" name=""/>
           <p:cNvCxnSpPr>
             <a:stCxn xmlns:a="http://schemas.openxmlformats.org/drawingml/2006/main" id="9" idx="1"/>
             <a:endCxn xmlns:a="http://schemas.openxmlformats.org/drawingml/2006/main" id="10" idx="3"/>
@@ -3774,7 +3598,7 @@
       </p:cxnSp>
       <p:cxnSp>
         <p:nvCxnSpPr>
-          <p:cNvPr id="201" name=""/>
+          <p:cNvPr id="297" name=""/>
           <p:cNvCxnSpPr>
             <a:stCxn xmlns:a="http://schemas.openxmlformats.org/drawingml/2006/main" id="10" idx="1"/>
             <a:endCxn xmlns:a="http://schemas.openxmlformats.org/drawingml/2006/main" id="11" idx="3"/>
@@ -3800,7 +3624,7 @@
       </p:cxnSp>
       <p:cxnSp>
         <p:nvCxnSpPr>
-          <p:cNvPr id="202" name=""/>
+          <p:cNvPr id="298" name=""/>
           <p:cNvCxnSpPr>
             <a:stCxn xmlns:a="http://schemas.openxmlformats.org/drawingml/2006/main" id="11" idx="1"/>
             <a:endCxn xmlns:a="http://schemas.openxmlformats.org/drawingml/2006/main" id="12" idx="1"/>
@@ -3826,7 +3650,7 @@
       </p:cxnSp>
       <p:cxnSp>
         <p:nvCxnSpPr>
-          <p:cNvPr id="203" name=""/>
+          <p:cNvPr id="299" name=""/>
           <p:cNvCxnSpPr>
             <a:stCxn xmlns:a="http://schemas.openxmlformats.org/drawingml/2006/main" id="12" idx="3"/>
             <a:endCxn xmlns:a="http://schemas.openxmlformats.org/drawingml/2006/main" id="13" idx="1"/>
@@ -3852,7 +3676,7 @@
       </p:cxnSp>
       <p:cxnSp>
         <p:nvCxnSpPr>
-          <p:cNvPr id="204" name=""/>
+          <p:cNvPr id="300" name=""/>
           <p:cNvCxnSpPr>
             <a:stCxn xmlns:a="http://schemas.openxmlformats.org/drawingml/2006/main" id="13" idx="3"/>
             <a:endCxn xmlns:a="http://schemas.openxmlformats.org/drawingml/2006/main" id="14" idx="1"/>
@@ -4056,7 +3880,7 @@
                 <a:ea typeface="Arial"/>
                 <a:cs typeface="Arial"/>
               </a:rPr>
-              <a:t>Temporal 80/20 split</a:t>
+              <a:t>Temporal data split</a:t>
             </a:r>
           </a:p>
         </p:txBody>
@@ -4091,7 +3915,7 @@
         </p:spPr>
         <p:txBody>
           <a:bodyPr xmlns:a="http://schemas.openxmlformats.org/drawingml/2006/main" lIns="19050" tIns="0" rIns="19050" bIns="0" anchor="t">
-            <a:normAutofit fontScale="98303"/>
+            <a:normAutofit fontScale="100000"/>
           </a:bodyPr>
           <a:lstStyle xmlns:a="http://schemas.openxmlformats.org/drawingml/2006/main"/>
           <a:p xmlns:a="http://schemas.openxmlformats.org/drawingml/2006/main">
@@ -4115,7 +3939,7 @@
                 <a:ea typeface="Arial"/>
                 <a:cs typeface="Arial"/>
               </a:rPr>
-              <a:t>Train on the earlier period; test on the later period</a:t>
+              <a:t>64% discovery, 16% validation, 20% final test</a:t>
             </a:r>
           </a:p>
         </p:txBody>
@@ -4457,7 +4281,7 @@
         </p:spPr>
         <p:txBody>
           <a:bodyPr xmlns:a="http://schemas.openxmlformats.org/drawingml/2006/main" lIns="19050" tIns="0" rIns="19050" bIns="0" anchor="t">
-            <a:normAutofit fontScale="96491"/>
+            <a:normAutofit fontScale="90828"/>
           </a:bodyPr>
           <a:lstStyle xmlns:a="http://schemas.openxmlformats.org/drawingml/2006/main"/>
           <a:p xmlns:a="http://schemas.openxmlformats.org/drawingml/2006/main">
@@ -4481,7 +4305,7 @@
                 <a:ea typeface="Arial"/>
                 <a:cs typeface="Arial"/>
               </a:rPr>
-              <a:t>Use sequential net; verify held-out language and case contract</a:t>
+              <a:t>Use sequential net and verify held-out language and case contract</a:t>
             </a:r>
           </a:p>
         </p:txBody>
@@ -4603,7 +4427,7 @@
                 <a:ea typeface="Arial"/>
                 <a:cs typeface="Arial"/>
               </a:rPr>
-              <a:t>2x2: static proxies off/on; native state off/on</a:t>
+              <a:t>2x2: static proxies off/on, native state off/on</a:t>
             </a:r>
           </a:p>
         </p:txBody>
@@ -4666,7 +4490,7 @@
                 <a:ea typeface="Arial"/>
                 <a:cs typeface="Arial"/>
               </a:rPr>
-              <a:t>Freeze bundles and cap RMGs</a:t>
+              <a:t>Select and freeze models</a:t>
             </a:r>
           </a:p>
         </p:txBody>
@@ -4701,7 +4525,7 @@
         </p:spPr>
         <p:txBody>
           <a:bodyPr xmlns:a="http://schemas.openxmlformats.org/drawingml/2006/main" lIns="19050" tIns="0" rIns="19050" bIns="0" anchor="t">
-            <a:normAutofit fontScale="94591"/>
+            <a:normAutofit fontScale="100000"/>
           </a:bodyPr>
           <a:lstStyle xmlns:a="http://schemas.openxmlformats.org/drawingml/2006/main"/>
           <a:p xmlns:a="http://schemas.openxmlformats.org/drawingml/2006/main">
@@ -4725,7 +4549,7 @@
                 <a:ea typeface="Arial"/>
                 <a:cs typeface="Arial"/>
               </a:rPr>
-              <a:t>Training-only bundles; max. three RMGs per block</a:t>
+              <a:t>Validate on 16%, refit on 80%, cap RMGs at three</a:t>
             </a:r>
           </a:p>
         </p:txBody>
@@ -4847,7 +4671,7 @@
                 <a:ea typeface="Arial"/>
                 <a:cs typeface="Arial"/>
               </a:rPr>
-              <a:t>Ten seeds (42--51) with 17,892 cases per run</a:t>
+              <a:t>Ten seeds (42--51), 17,892 test cases per run</a:t>
             </a:r>
           </a:p>
         </p:txBody>
@@ -4910,7 +4734,7 @@
                 <a:ea typeface="Arial"/>
                 <a:cs typeface="Arial"/>
               </a:rPr>
-              <a:t>Evaluate held-out fidelity</a:t>
+              <a:t>Evaluate untouched test</a:t>
             </a:r>
           </a:p>
         </p:txBody>
@@ -5189,7 +5013,7 @@
         </p:spPr>
         <p:txBody>
           <a:bodyPr xmlns:a="http://schemas.openxmlformats.org/drawingml/2006/main" lIns="19050" tIns="0" rIns="19050" bIns="0" anchor="t">
-            <a:normAutofit fontScale="96503"/>
+            <a:normAutofit fontScale="94484"/>
           </a:bodyPr>
           <a:lstStyle xmlns:a="http://schemas.openxmlformats.org/drawingml/2006/main"/>
           <a:p xmlns:a="http://schemas.openxmlformats.org/drawingml/2006/main">
@@ -5213,7 +5037,7 @@
                 <a:ea typeface="Arial"/>
                 <a:cs typeface="Arial"/>
               </a:rPr>
-              <a:t>T22 reallocation and 20% higher working-time truck demand</a:t>
+              <a:t>Native-only: T22 closure and 20% higher working-time demand</a:t>
             </a:r>
           </a:p>
         </p:txBody>

</xml_diff>